<commit_message>
colocando en español los titulos de los meses
</commit_message>
<xml_diff>
--- a/services/pptx/Plantilla.pptx
+++ b/services/pptx/Plantilla.pptx
@@ -142,7 +142,7 @@
         <p:spPr>
           <a:xfrm>
             <a:off x="862401" y="1002091"/>
-            <a:ext cx="3247523" cy="2627126"/>
+            <a:ext cx="3548732" cy="2627126"/>
           </a:xfrm>
           <a:prstGeom prst="rect">
             <a:avLst/>
@@ -161,8 +161,8 @@
         </p:nvSpPr>
         <p:spPr>
           <a:xfrm>
-            <a:off x="5071724" y="1002092"/>
-            <a:ext cx="3247523" cy="2627125"/>
+            <a:off x="4758268" y="1002092"/>
+            <a:ext cx="3560980" cy="2627125"/>
           </a:xfrm>
           <a:prstGeom prst="rect">
             <a:avLst/>

</xml_diff>